<commit_message>
Update: 2025-10-01 12:57:20 - mcp_knowledge_base/.cache_converted/cloud_intermediate/textbook/ref-docs/docker-and-kubernetes.pdf and 29 more files
</commit_message>
<xml_diff>
--- a/mcp_knowledge_base/cloud_intermediate/textbook/ref-docs/docker-multi-stage-build.pptx
+++ b/mcp_knowledge_base/cloud_intermediate/textbook/ref-docs/docker-multi-stage-build.pptx
@@ -7,16 +7,17 @@
   <p:sldIdLst>
     <p:sldId id="256" r:id="rId2"/>
     <p:sldId id="258" r:id="rId3"/>
-    <p:sldId id="260" r:id="rId4"/>
-    <p:sldId id="261" r:id="rId5"/>
-    <p:sldId id="262" r:id="rId6"/>
-    <p:sldId id="263" r:id="rId7"/>
-    <p:sldId id="264" r:id="rId8"/>
-    <p:sldId id="265" r:id="rId9"/>
-    <p:sldId id="266" r:id="rId10"/>
-    <p:sldId id="267" r:id="rId11"/>
-    <p:sldId id="268" r:id="rId12"/>
-    <p:sldId id="269" r:id="rId13"/>
+    <p:sldId id="259" r:id="rId4"/>
+    <p:sldId id="260" r:id="rId5"/>
+    <p:sldId id="261" r:id="rId6"/>
+    <p:sldId id="262" r:id="rId7"/>
+    <p:sldId id="263" r:id="rId8"/>
+    <p:sldId id="264" r:id="rId9"/>
+    <p:sldId id="265" r:id="rId10"/>
+    <p:sldId id="266" r:id="rId11"/>
+    <p:sldId id="267" r:id="rId12"/>
+    <p:sldId id="268" r:id="rId13"/>
+    <p:sldId id="269" r:id="rId14"/>
   </p:sldIdLst>
   <p:sldSz cx="13004800" cy="9753600"/>
   <p:notesSz cx="13004800" cy="9753600"/>
@@ -1594,6 +1595,120 @@
           </p:nvPr>
         </p:nvSpPr>
         <p:spPr>
+          <a:xfrm>
+            <a:off x="2006600" y="467359"/>
+            <a:ext cx="8988425" cy="2065655"/>
+          </a:xfrm>
+          <a:prstGeom prst="rect">
+            <a:avLst/>
+          </a:prstGeom>
+        </p:spPr>
+        <p:txBody>
+          <a:bodyPr vert="horz" wrap="square" lIns="0" tIns="33655" rIns="0" bIns="0" rtlCol="0">
+            <a:spAutoFit/>
+          </a:bodyPr>
+          <a:lstStyle/>
+          <a:p>
+            <a:pPr marL="2133600" marR="5080" indent="-2120900">
+              <a:lnSpc>
+                <a:spcPts val="8000"/>
+              </a:lnSpc>
+              <a:spcBef>
+                <a:spcPts val="265"/>
+              </a:spcBef>
+            </a:pPr>
+            <a:r>
+              <a:rPr sz="6700" spc="70" dirty="0"/>
+              <a:t>Docker</a:t>
+            </a:r>
+            <a:r>
+              <a:rPr sz="6700" spc="170" dirty="0"/>
+              <a:t> </a:t>
+            </a:r>
+            <a:r>
+              <a:rPr sz="6700" dirty="0"/>
+              <a:t>multi-stage</a:t>
+            </a:r>
+            <a:r>
+              <a:rPr sz="6700" spc="170" dirty="0"/>
+              <a:t> </a:t>
+            </a:r>
+            <a:r>
+              <a:rPr sz="6700" spc="-20" dirty="0"/>
+              <a:t>with </a:t>
+            </a:r>
+            <a:r>
+              <a:rPr sz="6700" u="sng" spc="-10" dirty="0">
+                <a:uFill>
+                  <a:solidFill>
+                    <a:srgbClr val="000000"/>
+                  </a:solidFill>
+                </a:uFill>
+              </a:rPr>
+              <a:t>codefresh.io</a:t>
+            </a:r>
+            <a:endParaRPr sz="6700"/>
+          </a:p>
+        </p:txBody>
+      </p:sp>
+      <p:pic>
+        <p:nvPicPr>
+          <p:cNvPr id="3" name="object 3"/>
+          <p:cNvPicPr/>
+          <p:nvPr/>
+        </p:nvPicPr>
+        <p:blipFill>
+          <a:blip r:embed="rId2" cstate="print"/>
+          <a:stretch>
+            <a:fillRect/>
+          </a:stretch>
+        </p:blipFill>
+        <p:spPr>
+          <a:xfrm>
+            <a:off x="0" y="2844800"/>
+            <a:ext cx="13004800" cy="6832623"/>
+          </a:xfrm>
+          <a:prstGeom prst="rect">
+            <a:avLst/>
+          </a:prstGeom>
+        </p:spPr>
+      </p:pic>
+    </p:spTree>
+  </p:cSld>
+  <p:clrMapOvr>
+    <a:masterClrMapping/>
+  </p:clrMapOvr>
+</p:sld>
+</file>
+
+<file path=ppt/slides/slide11.xml><?xml version="1.0" encoding="utf-8"?>
+<p:sld xmlns:a="http://schemas.openxmlformats.org/drawingml/2006/main" xmlns:r="http://schemas.openxmlformats.org/officeDocument/2006/relationships" xmlns:p="http://schemas.openxmlformats.org/presentationml/2006/main" showMasterSp="0">
+  <p:cSld>
+    <p:spTree>
+      <p:nvGrpSpPr>
+        <p:cNvPr id="1" name=""/>
+        <p:cNvGrpSpPr/>
+        <p:nvPr/>
+      </p:nvGrpSpPr>
+      <p:grpSpPr>
+        <a:xfrm>
+          <a:off x="0" y="0"/>
+          <a:ext cx="0" cy="0"/>
+          <a:chOff x="0" y="0"/>
+          <a:chExt cx="0" cy="0"/>
+        </a:xfrm>
+      </p:grpSpPr>
+      <p:sp>
+        <p:nvSpPr>
+          <p:cNvPr id="2" name="object 2"/>
+          <p:cNvSpPr txBox="1">
+            <a:spLocks noGrp="1"/>
+          </p:cNvSpPr>
+          <p:nvPr>
+            <p:ph type="title"/>
+          </p:nvPr>
+        </p:nvSpPr>
+        <p:spPr>
           <a:prstGeom prst="rect">
             <a:avLst/>
           </a:prstGeom>
@@ -2615,7 +2730,7 @@
 </p:sld>
 </file>
 
-<file path=ppt/slides/slide11.xml><?xml version="1.0" encoding="utf-8"?>
+<file path=ppt/slides/slide12.xml><?xml version="1.0" encoding="utf-8"?>
 <p:sld xmlns:a="http://schemas.openxmlformats.org/drawingml/2006/main" xmlns:r="http://schemas.openxmlformats.org/officeDocument/2006/relationships" xmlns:p="http://schemas.openxmlformats.org/presentationml/2006/main" showMasterSp="0">
   <p:cSld>
     <p:spTree>
@@ -3299,7 +3414,7 @@
 </p:sld>
 </file>
 
-<file path=ppt/slides/slide12.xml><?xml version="1.0" encoding="utf-8"?>
+<file path=ppt/slides/slide13.xml><?xml version="1.0" encoding="utf-8"?>
 <p:sld xmlns:a="http://schemas.openxmlformats.org/drawingml/2006/main" xmlns:r="http://schemas.openxmlformats.org/officeDocument/2006/relationships" xmlns:p="http://schemas.openxmlformats.org/presentationml/2006/main" showMasterSp="0">
   <p:cSld>
     <p:spTree>
@@ -4020,6 +4135,317 @@
 </file>
 
 <file path=ppt/slides/slide3.xml><?xml version="1.0" encoding="utf-8"?>
+<p:sld xmlns:a="http://schemas.openxmlformats.org/drawingml/2006/main" xmlns:r="http://schemas.openxmlformats.org/officeDocument/2006/relationships" xmlns:p="http://schemas.openxmlformats.org/presentationml/2006/main" showMasterSp="0">
+  <p:cSld>
+    <p:spTree>
+      <p:nvGrpSpPr>
+        <p:cNvPr id="1" name=""/>
+        <p:cNvGrpSpPr/>
+        <p:nvPr/>
+      </p:nvGrpSpPr>
+      <p:grpSpPr>
+        <a:xfrm>
+          <a:off x="0" y="0"/>
+          <a:ext cx="0" cy="0"/>
+          <a:chOff x="0" y="0"/>
+          <a:chExt cx="0" cy="0"/>
+        </a:xfrm>
+      </p:grpSpPr>
+      <p:grpSp>
+        <p:nvGrpSpPr>
+          <p:cNvPr id="2" name="object 2"/>
+          <p:cNvGrpSpPr/>
+          <p:nvPr/>
+        </p:nvGrpSpPr>
+        <p:grpSpPr>
+          <a:xfrm>
+            <a:off x="0" y="673100"/>
+            <a:ext cx="12992735" cy="7709534"/>
+            <a:chOff x="0" y="673100"/>
+            <a:chExt cx="12992735" cy="7709534"/>
+          </a:xfrm>
+        </p:grpSpPr>
+        <p:pic>
+          <p:nvPicPr>
+            <p:cNvPr id="3" name="object 3"/>
+            <p:cNvPicPr/>
+            <p:nvPr/>
+          </p:nvPicPr>
+          <p:blipFill>
+            <a:blip r:embed="rId2" cstate="print"/>
+            <a:stretch>
+              <a:fillRect/>
+            </a:stretch>
+          </p:blipFill>
+          <p:spPr>
+            <a:xfrm>
+              <a:off x="5231845" y="1663607"/>
+              <a:ext cx="7760274" cy="6718739"/>
+            </a:xfrm>
+            <a:prstGeom prst="rect">
+              <a:avLst/>
+            </a:prstGeom>
+          </p:spPr>
+        </p:pic>
+        <p:pic>
+          <p:nvPicPr>
+            <p:cNvPr id="4" name="object 4"/>
+            <p:cNvPicPr/>
+            <p:nvPr/>
+          </p:nvPicPr>
+          <p:blipFill>
+            <a:blip r:embed="rId3" cstate="print"/>
+            <a:stretch>
+              <a:fillRect/>
+            </a:stretch>
+          </p:blipFill>
+          <p:spPr>
+            <a:xfrm>
+              <a:off x="0" y="673100"/>
+              <a:ext cx="6070600" cy="4505537"/>
+            </a:xfrm>
+            <a:prstGeom prst="rect">
+              <a:avLst/>
+            </a:prstGeom>
+          </p:spPr>
+        </p:pic>
+      </p:grpSp>
+      <p:sp>
+        <p:nvSpPr>
+          <p:cNvPr id="5" name="object 5"/>
+          <p:cNvSpPr txBox="1">
+            <a:spLocks noGrp="1"/>
+          </p:cNvSpPr>
+          <p:nvPr>
+            <p:ph type="title"/>
+          </p:nvPr>
+        </p:nvSpPr>
+        <p:spPr>
+          <a:xfrm>
+            <a:off x="6146800" y="1079500"/>
+            <a:ext cx="6755130" cy="513080"/>
+          </a:xfrm>
+          <a:prstGeom prst="rect">
+            <a:avLst/>
+          </a:prstGeom>
+        </p:spPr>
+        <p:txBody>
+          <a:bodyPr vert="horz" wrap="square" lIns="0" tIns="12700" rIns="0" bIns="0" rtlCol="0">
+            <a:spAutoFit/>
+          </a:bodyPr>
+          <a:lstStyle/>
+          <a:p>
+            <a:pPr marL="12700">
+              <a:lnSpc>
+                <a:spcPct val="100000"/>
+              </a:lnSpc>
+              <a:spcBef>
+                <a:spcPts val="100"/>
+              </a:spcBef>
+            </a:pPr>
+            <a:r>
+              <a:rPr sz="3200" b="1" spc="-10" dirty="0">
+                <a:latin typeface="Arial"/>
+                <a:cs typeface="Arial"/>
+              </a:rPr>
+              <a:t>janloeffler/html-</a:t>
+            </a:r>
+            <a:r>
+              <a:rPr sz="3200" b="1" dirty="0">
+                <a:latin typeface="Arial"/>
+                <a:cs typeface="Arial"/>
+              </a:rPr>
+              <a:t>demo</a:t>
+            </a:r>
+            <a:r>
+              <a:rPr sz="3200" b="1" spc="105" dirty="0">
+                <a:latin typeface="Arial"/>
+                <a:cs typeface="Arial"/>
+              </a:rPr>
+              <a:t> </a:t>
+            </a:r>
+            <a:r>
+              <a:rPr sz="3200" dirty="0"/>
+              <a:t>Image</a:t>
+            </a:r>
+            <a:r>
+              <a:rPr sz="3200" spc="110" dirty="0"/>
+              <a:t> </a:t>
+            </a:r>
+            <a:r>
+              <a:rPr sz="3200" spc="-10" dirty="0"/>
+              <a:t>Layers</a:t>
+            </a:r>
+            <a:endParaRPr sz="3200">
+              <a:latin typeface="Arial"/>
+              <a:cs typeface="Arial"/>
+            </a:endParaRPr>
+          </a:p>
+        </p:txBody>
+      </p:sp>
+      <p:sp>
+        <p:nvSpPr>
+          <p:cNvPr id="6" name="object 6"/>
+          <p:cNvSpPr txBox="1"/>
+          <p:nvPr/>
+        </p:nvSpPr>
+        <p:spPr>
+          <a:xfrm>
+            <a:off x="3759200" y="4673600"/>
+            <a:ext cx="2233295" cy="391160"/>
+          </a:xfrm>
+          <a:prstGeom prst="rect">
+            <a:avLst/>
+          </a:prstGeom>
+        </p:spPr>
+        <p:txBody>
+          <a:bodyPr vert="horz" wrap="square" lIns="0" tIns="12700" rIns="0" bIns="0" rtlCol="0">
+            <a:spAutoFit/>
+          </a:bodyPr>
+          <a:lstStyle/>
+          <a:p>
+            <a:pPr marL="12700">
+              <a:lnSpc>
+                <a:spcPct val="100000"/>
+              </a:lnSpc>
+              <a:spcBef>
+                <a:spcPts val="100"/>
+              </a:spcBef>
+            </a:pPr>
+            <a:r>
+              <a:rPr sz="2400" dirty="0">
+                <a:solidFill>
+                  <a:srgbClr val="0365C0"/>
+                </a:solidFill>
+                <a:latin typeface="Arial"/>
+                <a:cs typeface="Arial"/>
+              </a:rPr>
+              <a:t>nginx</a:t>
+            </a:r>
+            <a:r>
+              <a:rPr sz="2400" spc="114" dirty="0">
+                <a:solidFill>
+                  <a:srgbClr val="0365C0"/>
+                </a:solidFill>
+                <a:latin typeface="Arial"/>
+                <a:cs typeface="Arial"/>
+              </a:rPr>
+              <a:t> </a:t>
+            </a:r>
+            <a:r>
+              <a:rPr sz="2400" spc="-10" dirty="0">
+                <a:solidFill>
+                  <a:srgbClr val="0365C0"/>
+                </a:solidFill>
+                <a:latin typeface="Arial"/>
+                <a:cs typeface="Arial"/>
+              </a:rPr>
+              <a:t>Dockerfile</a:t>
+            </a:r>
+            <a:endParaRPr sz="2400">
+              <a:latin typeface="Arial"/>
+              <a:cs typeface="Arial"/>
+            </a:endParaRPr>
+          </a:p>
+        </p:txBody>
+      </p:sp>
+      <p:pic>
+        <p:nvPicPr>
+          <p:cNvPr id="7" name="object 7"/>
+          <p:cNvPicPr/>
+          <p:nvPr/>
+        </p:nvPicPr>
+        <p:blipFill>
+          <a:blip r:embed="rId4" cstate="print"/>
+          <a:stretch>
+            <a:fillRect/>
+          </a:stretch>
+        </p:blipFill>
+        <p:spPr>
+          <a:xfrm>
+            <a:off x="25261" y="5346662"/>
+            <a:ext cx="4597538" cy="4292528"/>
+          </a:xfrm>
+          <a:prstGeom prst="rect">
+            <a:avLst/>
+          </a:prstGeom>
+        </p:spPr>
+      </p:pic>
+      <p:sp>
+        <p:nvSpPr>
+          <p:cNvPr id="8" name="object 8"/>
+          <p:cNvSpPr txBox="1"/>
+          <p:nvPr/>
+        </p:nvSpPr>
+        <p:spPr>
+          <a:xfrm>
+            <a:off x="3403600" y="9194800"/>
+            <a:ext cx="2943860" cy="391160"/>
+          </a:xfrm>
+          <a:prstGeom prst="rect">
+            <a:avLst/>
+          </a:prstGeom>
+        </p:spPr>
+        <p:txBody>
+          <a:bodyPr vert="horz" wrap="square" lIns="0" tIns="12700" rIns="0" bIns="0" rtlCol="0">
+            <a:spAutoFit/>
+          </a:bodyPr>
+          <a:lstStyle/>
+          <a:p>
+            <a:pPr marL="12700">
+              <a:lnSpc>
+                <a:spcPct val="100000"/>
+              </a:lnSpc>
+              <a:spcBef>
+                <a:spcPts val="100"/>
+              </a:spcBef>
+            </a:pPr>
+            <a:r>
+              <a:rPr sz="2400" dirty="0">
+                <a:solidFill>
+                  <a:srgbClr val="0365C0"/>
+                </a:solidFill>
+                <a:latin typeface="Arial"/>
+                <a:cs typeface="Arial"/>
+              </a:rPr>
+              <a:t>html-demo</a:t>
+            </a:r>
+            <a:r>
+              <a:rPr sz="2400" spc="110" dirty="0">
+                <a:solidFill>
+                  <a:srgbClr val="0365C0"/>
+                </a:solidFill>
+                <a:latin typeface="Arial"/>
+                <a:cs typeface="Arial"/>
+              </a:rPr>
+              <a:t> </a:t>
+            </a:r>
+            <a:r>
+              <a:rPr sz="2400" spc="-10" dirty="0">
+                <a:solidFill>
+                  <a:srgbClr val="0365C0"/>
+                </a:solidFill>
+                <a:latin typeface="Arial"/>
+                <a:cs typeface="Arial"/>
+              </a:rPr>
+              <a:t>Dockerfile</a:t>
+            </a:r>
+            <a:endParaRPr sz="2400">
+              <a:latin typeface="Arial"/>
+              <a:cs typeface="Arial"/>
+            </a:endParaRPr>
+          </a:p>
+        </p:txBody>
+      </p:sp>
+    </p:spTree>
+  </p:cSld>
+  <p:clrMapOvr>
+    <a:masterClrMapping/>
+  </p:clrMapOvr>
+</p:sld>
+</file>
+
+<file path=ppt/slides/slide4.xml><?xml version="1.0" encoding="utf-8"?>
 <p:sld xmlns:a="http://schemas.openxmlformats.org/drawingml/2006/main" xmlns:r="http://schemas.openxmlformats.org/officeDocument/2006/relationships" xmlns:p="http://schemas.openxmlformats.org/presentationml/2006/main" showMasterSp="0">
   <p:cSld>
     <p:spTree>
@@ -5052,7 +5478,7 @@
 </p:sld>
 </file>
 
-<file path=ppt/slides/slide4.xml><?xml version="1.0" encoding="utf-8"?>
+<file path=ppt/slides/slide5.xml><?xml version="1.0" encoding="utf-8"?>
 <p:sld xmlns:a="http://schemas.openxmlformats.org/drawingml/2006/main" xmlns:r="http://schemas.openxmlformats.org/officeDocument/2006/relationships" xmlns:p="http://schemas.openxmlformats.org/presentationml/2006/main" showMasterSp="0">
   <p:cSld>
     <p:spTree>
@@ -5589,7 +6015,7 @@
 </p:sld>
 </file>
 
-<file path=ppt/slides/slide5.xml><?xml version="1.0" encoding="utf-8"?>
+<file path=ppt/slides/slide6.xml><?xml version="1.0" encoding="utf-8"?>
 <p:sld xmlns:a="http://schemas.openxmlformats.org/drawingml/2006/main" xmlns:r="http://schemas.openxmlformats.org/officeDocument/2006/relationships" xmlns:p="http://schemas.openxmlformats.org/presentationml/2006/main" showMasterSp="0">
   <p:cSld>
     <p:spTree>
@@ -6050,7 +6476,7 @@
 </p:sld>
 </file>
 
-<file path=ppt/slides/slide6.xml><?xml version="1.0" encoding="utf-8"?>
+<file path=ppt/slides/slide7.xml><?xml version="1.0" encoding="utf-8"?>
 <p:sld xmlns:a="http://schemas.openxmlformats.org/drawingml/2006/main" xmlns:r="http://schemas.openxmlformats.org/officeDocument/2006/relationships" xmlns:p="http://schemas.openxmlformats.org/presentationml/2006/main" showMasterSp="0">
   <p:cSld>
     <p:spTree>
@@ -8136,7 +8562,7 @@
 </p:sld>
 </file>
 
-<file path=ppt/slides/slide7.xml><?xml version="1.0" encoding="utf-8"?>
+<file path=ppt/slides/slide8.xml><?xml version="1.0" encoding="utf-8"?>
 <p:sld xmlns:a="http://schemas.openxmlformats.org/drawingml/2006/main" xmlns:r="http://schemas.openxmlformats.org/officeDocument/2006/relationships" xmlns:p="http://schemas.openxmlformats.org/presentationml/2006/main" showMasterSp="0">
   <p:cSld>
     <p:spTree>
@@ -8289,7 +8715,7 @@
         </p:nvGraphicFramePr>
         <p:xfrm>
           <a:off x="3981450" y="3282950"/>
-          <a:ext cx="8441055" cy="6226175"/>
+          <a:ext cx="8531225" cy="6226175"/>
         </p:xfrm>
         <a:graphic>
           <a:graphicData uri="http://schemas.openxmlformats.org/drawingml/2006/table">
@@ -10301,7 +10727,7 @@
 </p:sld>
 </file>
 
-<file path=ppt/slides/slide8.xml><?xml version="1.0" encoding="utf-8"?>
+<file path=ppt/slides/slide9.xml><?xml version="1.0" encoding="utf-8"?>
 <p:sld xmlns:a="http://schemas.openxmlformats.org/drawingml/2006/main" xmlns:r="http://schemas.openxmlformats.org/officeDocument/2006/relationships" xmlns:p="http://schemas.openxmlformats.org/presentationml/2006/main" showMasterSp="0">
   <p:cSld>
     <p:spTree>
@@ -11332,120 +11758,6 @@
           </a:p>
         </p:txBody>
       </p:sp>
-    </p:spTree>
-  </p:cSld>
-  <p:clrMapOvr>
-    <a:masterClrMapping/>
-  </p:clrMapOvr>
-</p:sld>
-</file>
-
-<file path=ppt/slides/slide9.xml><?xml version="1.0" encoding="utf-8"?>
-<p:sld xmlns:a="http://schemas.openxmlformats.org/drawingml/2006/main" xmlns:r="http://schemas.openxmlformats.org/officeDocument/2006/relationships" xmlns:p="http://schemas.openxmlformats.org/presentationml/2006/main" showMasterSp="0">
-  <p:cSld>
-    <p:spTree>
-      <p:nvGrpSpPr>
-        <p:cNvPr id="1" name=""/>
-        <p:cNvGrpSpPr/>
-        <p:nvPr/>
-      </p:nvGrpSpPr>
-      <p:grpSpPr>
-        <a:xfrm>
-          <a:off x="0" y="0"/>
-          <a:ext cx="0" cy="0"/>
-          <a:chOff x="0" y="0"/>
-          <a:chExt cx="0" cy="0"/>
-        </a:xfrm>
-      </p:grpSpPr>
-      <p:sp>
-        <p:nvSpPr>
-          <p:cNvPr id="2" name="object 2"/>
-          <p:cNvSpPr txBox="1">
-            <a:spLocks noGrp="1"/>
-          </p:cNvSpPr>
-          <p:nvPr>
-            <p:ph type="title"/>
-          </p:nvPr>
-        </p:nvSpPr>
-        <p:spPr>
-          <a:xfrm>
-            <a:off x="2006600" y="467359"/>
-            <a:ext cx="8988425" cy="2065655"/>
-          </a:xfrm>
-          <a:prstGeom prst="rect">
-            <a:avLst/>
-          </a:prstGeom>
-        </p:spPr>
-        <p:txBody>
-          <a:bodyPr vert="horz" wrap="square" lIns="0" tIns="33655" rIns="0" bIns="0" rtlCol="0">
-            <a:spAutoFit/>
-          </a:bodyPr>
-          <a:lstStyle/>
-          <a:p>
-            <a:pPr marL="2133600" marR="5080" indent="-2120900">
-              <a:lnSpc>
-                <a:spcPts val="8000"/>
-              </a:lnSpc>
-              <a:spcBef>
-                <a:spcPts val="265"/>
-              </a:spcBef>
-            </a:pPr>
-            <a:r>
-              <a:rPr sz="6700" spc="70" dirty="0"/>
-              <a:t>Docker</a:t>
-            </a:r>
-            <a:r>
-              <a:rPr sz="6700" spc="170" dirty="0"/>
-              <a:t> </a:t>
-            </a:r>
-            <a:r>
-              <a:rPr sz="6700" dirty="0"/>
-              <a:t>multi-stage</a:t>
-            </a:r>
-            <a:r>
-              <a:rPr sz="6700" spc="170" dirty="0"/>
-              <a:t> </a:t>
-            </a:r>
-            <a:r>
-              <a:rPr sz="6700" spc="-20" dirty="0"/>
-              <a:t>with </a:t>
-            </a:r>
-            <a:r>
-              <a:rPr sz="6700" u="sng" spc="-10" dirty="0">
-                <a:uFill>
-                  <a:solidFill>
-                    <a:srgbClr val="000000"/>
-                  </a:solidFill>
-                </a:uFill>
-              </a:rPr>
-              <a:t>codefresh.io</a:t>
-            </a:r>
-            <a:endParaRPr sz="6700"/>
-          </a:p>
-        </p:txBody>
-      </p:sp>
-      <p:pic>
-        <p:nvPicPr>
-          <p:cNvPr id="3" name="object 3"/>
-          <p:cNvPicPr/>
-          <p:nvPr/>
-        </p:nvPicPr>
-        <p:blipFill>
-          <a:blip r:embed="rId2" cstate="print"/>
-          <a:stretch>
-            <a:fillRect/>
-          </a:stretch>
-        </p:blipFill>
-        <p:spPr>
-          <a:xfrm>
-            <a:off x="0" y="2844800"/>
-            <a:ext cx="13004800" cy="6832623"/>
-          </a:xfrm>
-          <a:prstGeom prst="rect">
-            <a:avLst/>
-          </a:prstGeom>
-        </p:spPr>
-      </p:pic>
     </p:spTree>
   </p:cSld>
   <p:clrMapOvr>

</xml_diff>